<commit_message>
Rebuild the discovery deck with current-site screenshots
Screenshots now show the preview in Pamar's brand with real projects,
the deck accent matches Pamar yellow, and the "already working" stats
reflect the current site (6 real projects, 37 pages, 4 forms, 106
tests). Speaker notes stay removed for this public copy.

Co-Authored-By: Claude Opus 5.5 <noreply@anthropic.com>
Claude-Session: https://claude.ai/code/session_01PAApdVdrQKivNEr5CiiNPB
</commit_message>
<xml_diff>
--- a/docs/proposal/Pamar_Website_Discovery_Deck.pptx
+++ b/docs/proposal/Pamar_Website_Discovery_Deck.pptx
@@ -2058,7 +2058,7 @@
             <a:r>
               <a:rPr lang="en-US" sz="1200" b="1" spc="300" kern="0" dirty="0">
                 <a:solidFill>
-                  <a:srgbClr val="F2A900"/>
+                  <a:srgbClr val="F7C92D"/>
                 </a:solidFill>
                 <a:latin typeface="Arial" pitchFamily="34" charset="0"/>
                 <a:ea typeface="Arial" pitchFamily="34" charset="-122"/>
@@ -2361,11 +2361,11 @@
             <a:avLst/>
           </a:prstGeom>
           <a:solidFill>
-            <a:srgbClr val="F2A900"/>
+            <a:srgbClr val="F7C92D"/>
           </a:solidFill>
           <a:ln w="12700">
             <a:solidFill>
-              <a:srgbClr val="F2A900"/>
+              <a:srgbClr val="F7C92D"/>
             </a:solidFill>
             <a:prstDash val="solid"/>
           </a:ln>
@@ -2488,11 +2488,11 @@
             <a:avLst/>
           </a:prstGeom>
           <a:solidFill>
-            <a:srgbClr val="F2A900"/>
+            <a:srgbClr val="F7C92D"/>
           </a:solidFill>
           <a:ln w="12700">
             <a:solidFill>
-              <a:srgbClr val="F2A900"/>
+              <a:srgbClr val="F7C92D"/>
             </a:solidFill>
             <a:prstDash val="solid"/>
           </a:ln>
@@ -2615,11 +2615,11 @@
             <a:avLst/>
           </a:prstGeom>
           <a:solidFill>
-            <a:srgbClr val="F2A900"/>
+            <a:srgbClr val="F7C92D"/>
           </a:solidFill>
           <a:ln w="12700">
             <a:solidFill>
-              <a:srgbClr val="F2A900"/>
+              <a:srgbClr val="F7C92D"/>
             </a:solidFill>
             <a:prstDash val="solid"/>
           </a:ln>
@@ -2742,11 +2742,11 @@
             <a:avLst/>
           </a:prstGeom>
           <a:solidFill>
-            <a:srgbClr val="F2A900"/>
+            <a:srgbClr val="F7C92D"/>
           </a:solidFill>
           <a:ln w="12700">
             <a:solidFill>
-              <a:srgbClr val="F2A900"/>
+              <a:srgbClr val="F7C92D"/>
             </a:solidFill>
             <a:prstDash val="solid"/>
           </a:ln>
@@ -2869,11 +2869,11 @@
             <a:avLst/>
           </a:prstGeom>
           <a:solidFill>
-            <a:srgbClr val="F2A900"/>
+            <a:srgbClr val="F7C92D"/>
           </a:solidFill>
           <a:ln w="12700">
             <a:solidFill>
-              <a:srgbClr val="F2A900"/>
+              <a:srgbClr val="F7C92D"/>
             </a:solidFill>
             <a:prstDash val="solid"/>
           </a:ln>
@@ -2996,11 +2996,11 @@
             <a:avLst/>
           </a:prstGeom>
           <a:solidFill>
-            <a:srgbClr val="F2A900"/>
+            <a:srgbClr val="F7C92D"/>
           </a:solidFill>
           <a:ln w="12700">
             <a:solidFill>
-              <a:srgbClr val="F2A900"/>
+              <a:srgbClr val="F7C92D"/>
             </a:solidFill>
             <a:prstDash val="solid"/>
           </a:ln>
@@ -3477,7 +3477,7 @@
             <a:r>
               <a:rPr lang="en-US" sz="1200" b="1" spc="300" kern="0" dirty="0">
                 <a:solidFill>
-                  <a:srgbClr val="F2A900"/>
+                  <a:srgbClr val="F7C92D"/>
                 </a:solidFill>
                 <a:latin typeface="Arial" pitchFamily="34" charset="0"/>
                 <a:ea typeface="Arial" pitchFamily="34" charset="-122"/>
@@ -3555,13 +3555,13 @@
             <a:r>
               <a:rPr lang="en-US" sz="5400" b="1" dirty="0">
                 <a:solidFill>
-                  <a:srgbClr val="F2A900"/>
+                  <a:srgbClr val="F7C92D"/>
                 </a:solidFill>
                 <a:latin typeface="Arial" pitchFamily="34" charset="0"/>
                 <a:ea typeface="Arial" pitchFamily="34" charset="-122"/>
                 <a:cs typeface="Arial" pitchFamily="34" charset="-120"/>
               </a:rPr>
-              <a:t>10</a:t>
+              <a:t>6</a:t>
             </a:r>
             <a:endParaRPr lang="en-US" sz="5400" dirty="0"/>
           </a:p>
@@ -3600,7 +3600,7 @@
                 <a:ea typeface="Calibri" pitchFamily="34" charset="-122"/>
                 <a:cs typeface="Calibri" pitchFamily="34" charset="-120"/>
               </a:rPr>
-              <a:t>features built</a:t>
+              <a:t>real Pamar projects</a:t>
             </a:r>
             <a:endParaRPr lang="en-US" sz="1400" dirty="0"/>
           </a:p>
@@ -3633,13 +3633,13 @@
             <a:r>
               <a:rPr lang="en-US" sz="5400" b="1" dirty="0">
                 <a:solidFill>
-                  <a:srgbClr val="F2A900"/>
+                  <a:srgbClr val="F7C92D"/>
                 </a:solidFill>
                 <a:latin typeface="Arial" pitchFamily="34" charset="0"/>
                 <a:ea typeface="Arial" pitchFamily="34" charset="-122"/>
                 <a:cs typeface="Arial" pitchFamily="34" charset="-120"/>
               </a:rPr>
-              <a:t>36</a:t>
+              <a:t>37</a:t>
             </a:r>
             <a:endParaRPr lang="en-US" sz="5400" dirty="0"/>
           </a:p>
@@ -3678,7 +3678,7 @@
                 <a:ea typeface="Calibri" pitchFamily="34" charset="-122"/>
                 <a:cs typeface="Calibri" pitchFamily="34" charset="-120"/>
               </a:rPr>
-              <a:t>pages live in the prototype</a:t>
+              <a:t>pages live in the preview</a:t>
             </a:r>
             <a:endParaRPr lang="en-US" sz="1400" dirty="0"/>
           </a:p>
@@ -3711,7 +3711,7 @@
             <a:r>
               <a:rPr lang="en-US" sz="5400" b="1" dirty="0">
                 <a:solidFill>
-                  <a:srgbClr val="F2A900"/>
+                  <a:srgbClr val="F7C92D"/>
                 </a:solidFill>
                 <a:latin typeface="Arial" pitchFamily="34" charset="0"/>
                 <a:ea typeface="Arial" pitchFamily="34" charset="-122"/>
@@ -3789,13 +3789,13 @@
             <a:r>
               <a:rPr lang="en-US" sz="5400" b="1" dirty="0">
                 <a:solidFill>
-                  <a:srgbClr val="F2A900"/>
+                  <a:srgbClr val="F7C92D"/>
                 </a:solidFill>
                 <a:latin typeface="Arial" pitchFamily="34" charset="0"/>
                 <a:ea typeface="Arial" pitchFamily="34" charset="-122"/>
                 <a:cs typeface="Arial" pitchFamily="34" charset="-120"/>
               </a:rPr>
-              <a:t>94</a:t>
+              <a:t>106</a:t>
             </a:r>
             <a:endParaRPr lang="en-US" sz="5400" dirty="0"/>
           </a:p>
@@ -3873,7 +3873,7 @@
                 <a:ea typeface="Calibri" pitchFamily="34" charset="-122"/>
                 <a:cs typeface="Calibri" pitchFamily="34" charset="-120"/>
               </a:rPr>
-              <a:t>Core pages, the careers funnel, and the bid portal already run end to end with placeholder content. The build phases turn it into Pamar’s site: your brand, your projects, your CMS.</a:t>
+              <a:t>Core pages, the careers funnel, and the bid portal already run end to end, in Pamar’s brand with real projects and company history. The build phases add the CMS, staff tools, and launch.</a:t>
             </a:r>
             <a:endParaRPr lang="en-US" sz="1600" dirty="0"/>
           </a:p>
@@ -3906,7 +3906,7 @@
             <a:r>
               <a:rPr lang="en-US" sz="1400" i="1" dirty="0">
                 <a:solidFill>
-                  <a:srgbClr val="F2A900"/>
+                  <a:srgbClr val="F7C92D"/>
                 </a:solidFill>
                 <a:latin typeface="Calibri" pitchFamily="34" charset="0"/>
                 <a:ea typeface="Calibri" pitchFamily="34" charset="-122"/>
@@ -5027,11 +5027,11 @@
             </a:avLst>
           </a:prstGeom>
           <a:solidFill>
-            <a:srgbClr val="F2A900"/>
+            <a:srgbClr val="F7C92D"/>
           </a:solidFill>
           <a:ln w="12700">
             <a:solidFill>
-              <a:srgbClr val="F2A900"/>
+              <a:srgbClr val="F7C92D"/>
             </a:solidFill>
             <a:prstDash val="solid"/>
           </a:ln>
@@ -5623,11 +5623,11 @@
             <a:avLst/>
           </a:prstGeom>
           <a:solidFill>
-            <a:srgbClr val="F2A900"/>
+            <a:srgbClr val="F7C92D"/>
           </a:solidFill>
           <a:ln w="12700">
             <a:solidFill>
-              <a:srgbClr val="F2A900"/>
+              <a:srgbClr val="F7C92D"/>
             </a:solidFill>
             <a:prstDash val="solid"/>
           </a:ln>
@@ -5898,11 +5898,11 @@
             <a:avLst/>
           </a:prstGeom>
           <a:solidFill>
-            <a:srgbClr val="F2A900"/>
+            <a:srgbClr val="F7C92D"/>
           </a:solidFill>
           <a:ln w="12700">
             <a:solidFill>
-              <a:srgbClr val="F2A900"/>
+              <a:srgbClr val="F7C92D"/>
             </a:solidFill>
             <a:prstDash val="solid"/>
           </a:ln>
@@ -6173,11 +6173,11 @@
             <a:avLst/>
           </a:prstGeom>
           <a:solidFill>
-            <a:srgbClr val="F2A900"/>
+            <a:srgbClr val="F7C92D"/>
           </a:solidFill>
           <a:ln w="12700">
             <a:solidFill>
-              <a:srgbClr val="F2A900"/>
+              <a:srgbClr val="F7C92D"/>
             </a:solidFill>
             <a:prstDash val="solid"/>
           </a:ln>
@@ -6288,7 +6288,7 @@
             <a:r>
               <a:rPr lang="en-US" sz="1500" i="1" dirty="0">
                 <a:solidFill>
-                  <a:srgbClr val="F2A900"/>
+                  <a:srgbClr val="F7C92D"/>
                 </a:solidFill>
                 <a:latin typeface="Calibri" pitchFamily="34" charset="0"/>
                 <a:ea typeface="Calibri" pitchFamily="34" charset="-122"/>
@@ -6948,11 +6948,11 @@
             </a:avLst>
           </a:prstGeom>
           <a:solidFill>
-            <a:srgbClr val="F2A900"/>
+            <a:srgbClr val="F7C92D"/>
           </a:solidFill>
           <a:ln w="12700">
             <a:solidFill>
-              <a:srgbClr val="F2A900"/>
+              <a:srgbClr val="F7C92D"/>
             </a:solidFill>
             <a:prstDash val="solid"/>
           </a:ln>
@@ -7063,7 +7063,7 @@
             <a:r>
               <a:rPr lang="en-US" sz="1900" b="1" dirty="0">
                 <a:solidFill>
-                  <a:srgbClr val="F2A900"/>
+                  <a:srgbClr val="F7C92D"/>
                 </a:solidFill>
                 <a:latin typeface="Arial" pitchFamily="34" charset="0"/>
                 <a:ea typeface="Arial" pitchFamily="34" charset="-122"/>
@@ -7688,7 +7688,7 @@
             <a:r>
               <a:rPr lang="en-US" sz="1200" b="1" spc="300" kern="0" dirty="0">
                 <a:solidFill>
-                  <a:srgbClr val="F2A900"/>
+                  <a:srgbClr val="F7C92D"/>
                 </a:solidFill>
                 <a:latin typeface="Arial" pitchFamily="34" charset="0"/>
                 <a:ea typeface="Arial" pitchFamily="34" charset="-122"/>
@@ -7754,11 +7754,11 @@
             <a:avLst/>
           </a:prstGeom>
           <a:solidFill>
-            <a:srgbClr val="F2A900"/>
+            <a:srgbClr val="F7C92D"/>
           </a:solidFill>
           <a:ln w="12700">
             <a:solidFill>
-              <a:srgbClr val="F2A900"/>
+              <a:srgbClr val="F7C92D"/>
             </a:solidFill>
             <a:prstDash val="solid"/>
           </a:ln>
@@ -7896,11 +7896,11 @@
             <a:avLst/>
           </a:prstGeom>
           <a:solidFill>
-            <a:srgbClr val="F2A900"/>
+            <a:srgbClr val="F7C92D"/>
           </a:solidFill>
           <a:ln w="12700">
             <a:solidFill>
-              <a:srgbClr val="F2A900"/>
+              <a:srgbClr val="F7C92D"/>
             </a:solidFill>
             <a:prstDash val="solid"/>
           </a:ln>
@@ -8038,11 +8038,11 @@
             <a:avLst/>
           </a:prstGeom>
           <a:solidFill>
-            <a:srgbClr val="F2A900"/>
+            <a:srgbClr val="F7C92D"/>
           </a:solidFill>
           <a:ln w="12700">
             <a:solidFill>
-              <a:srgbClr val="F2A900"/>
+              <a:srgbClr val="F7C92D"/>
             </a:solidFill>
             <a:prstDash val="solid"/>
           </a:ln>
@@ -8180,11 +8180,11 @@
             <a:avLst/>
           </a:prstGeom>
           <a:solidFill>
-            <a:srgbClr val="F2A900"/>
+            <a:srgbClr val="F7C92D"/>
           </a:solidFill>
           <a:ln w="12700">
             <a:solidFill>
-              <a:srgbClr val="F2A900"/>
+              <a:srgbClr val="F7C92D"/>
             </a:solidFill>
             <a:prstDash val="solid"/>
           </a:ln>
@@ -8373,7 +8373,7 @@
             <a:r>
               <a:rPr lang="en-US" sz="1500" i="1" dirty="0">
                 <a:solidFill>
-                  <a:srgbClr val="F2A900"/>
+                  <a:srgbClr val="F7C92D"/>
                 </a:solidFill>
                 <a:latin typeface="Calibri" pitchFamily="34" charset="0"/>
                 <a:ea typeface="Calibri" pitchFamily="34" charset="-122"/>
@@ -8530,11 +8530,11 @@
             <a:avLst/>
           </a:prstGeom>
           <a:solidFill>
-            <a:srgbClr val="F2A900"/>
+            <a:srgbClr val="F7C92D"/>
           </a:solidFill>
           <a:ln w="12700">
             <a:solidFill>
-              <a:srgbClr val="F2A900"/>
+              <a:srgbClr val="F7C92D"/>
             </a:solidFill>
             <a:prstDash val="solid"/>
           </a:ln>
@@ -8684,11 +8684,11 @@
             <a:avLst/>
           </a:prstGeom>
           <a:solidFill>
-            <a:srgbClr val="F2A900"/>
+            <a:srgbClr val="F7C92D"/>
           </a:solidFill>
           <a:ln w="12700">
             <a:solidFill>
-              <a:srgbClr val="F2A900"/>
+              <a:srgbClr val="F7C92D"/>
             </a:solidFill>
             <a:prstDash val="solid"/>
           </a:ln>
@@ -8838,11 +8838,11 @@
             <a:avLst/>
           </a:prstGeom>
           <a:solidFill>
-            <a:srgbClr val="F2A900"/>
+            <a:srgbClr val="F7C92D"/>
           </a:solidFill>
           <a:ln w="12700">
             <a:solidFill>
-              <a:srgbClr val="F2A900"/>
+              <a:srgbClr val="F7C92D"/>
             </a:solidFill>
             <a:prstDash val="solid"/>
           </a:ln>
@@ -9347,11 +9347,11 @@
             <a:avLst/>
           </a:prstGeom>
           <a:solidFill>
-            <a:srgbClr val="F2A900"/>
+            <a:srgbClr val="F7C92D"/>
           </a:solidFill>
           <a:ln w="12700">
             <a:solidFill>
-              <a:srgbClr val="F2A900"/>
+              <a:srgbClr val="F7C92D"/>
             </a:solidFill>
             <a:prstDash val="solid"/>
           </a:ln>
@@ -9612,11 +9612,11 @@
             <a:avLst/>
           </a:prstGeom>
           <a:solidFill>
-            <a:srgbClr val="F2A900"/>
+            <a:srgbClr val="F7C92D"/>
           </a:solidFill>
           <a:ln w="12700">
             <a:solidFill>
-              <a:srgbClr val="F2A900"/>
+              <a:srgbClr val="F7C92D"/>
             </a:solidFill>
             <a:prstDash val="solid"/>
           </a:ln>
@@ -9877,11 +9877,11 @@
             <a:avLst/>
           </a:prstGeom>
           <a:solidFill>
-            <a:srgbClr val="F2A900"/>
+            <a:srgbClr val="F7C92D"/>
           </a:solidFill>
           <a:ln w="12700">
             <a:solidFill>
-              <a:srgbClr val="F2A900"/>
+              <a:srgbClr val="F7C92D"/>
             </a:solidFill>
             <a:prstDash val="solid"/>
           </a:ln>
@@ -10273,11 +10273,11 @@
             <a:avLst/>
           </a:prstGeom>
           <a:solidFill>
-            <a:srgbClr val="F2A900"/>
+            <a:srgbClr val="F7C92D"/>
           </a:solidFill>
           <a:ln w="12700">
             <a:solidFill>
-              <a:srgbClr val="F2A900"/>
+              <a:srgbClr val="F7C92D"/>
             </a:solidFill>
             <a:prstDash val="solid"/>
           </a:ln>
@@ -10400,11 +10400,11 @@
             <a:avLst/>
           </a:prstGeom>
           <a:solidFill>
-            <a:srgbClr val="F2A900"/>
+            <a:srgbClr val="F7C92D"/>
           </a:solidFill>
           <a:ln w="12700">
             <a:solidFill>
-              <a:srgbClr val="F2A900"/>
+              <a:srgbClr val="F7C92D"/>
             </a:solidFill>
             <a:prstDash val="solid"/>
           </a:ln>
@@ -10527,11 +10527,11 @@
             <a:avLst/>
           </a:prstGeom>
           <a:solidFill>
-            <a:srgbClr val="F2A900"/>
+            <a:srgbClr val="F7C92D"/>
           </a:solidFill>
           <a:ln w="12700">
             <a:solidFill>
-              <a:srgbClr val="F2A900"/>
+              <a:srgbClr val="F7C92D"/>
             </a:solidFill>
             <a:prstDash val="solid"/>
           </a:ln>
@@ -10654,11 +10654,11 @@
             <a:avLst/>
           </a:prstGeom>
           <a:solidFill>
-            <a:srgbClr val="F2A900"/>
+            <a:srgbClr val="F7C92D"/>
           </a:solidFill>
           <a:ln w="12700">
             <a:solidFill>
-              <a:srgbClr val="F2A900"/>
+              <a:srgbClr val="F7C92D"/>
             </a:solidFill>
             <a:prstDash val="solid"/>
           </a:ln>
@@ -11018,11 +11018,11 @@
             <a:avLst/>
           </a:prstGeom>
           <a:solidFill>
-            <a:srgbClr val="F2A900"/>
+            <a:srgbClr val="F7C92D"/>
           </a:solidFill>
           <a:ln w="12700">
             <a:solidFill>
-              <a:srgbClr val="F2A900"/>
+              <a:srgbClr val="F7C92D"/>
             </a:solidFill>
             <a:prstDash val="solid"/>
           </a:ln>
@@ -11160,11 +11160,11 @@
             <a:avLst/>
           </a:prstGeom>
           <a:solidFill>
-            <a:srgbClr val="F2A900"/>
+            <a:srgbClr val="F7C92D"/>
           </a:solidFill>
           <a:ln w="12700">
             <a:solidFill>
-              <a:srgbClr val="F2A900"/>
+              <a:srgbClr val="F7C92D"/>
             </a:solidFill>
             <a:prstDash val="solid"/>
           </a:ln>
@@ -11302,11 +11302,11 @@
             <a:avLst/>
           </a:prstGeom>
           <a:solidFill>
-            <a:srgbClr val="F2A900"/>
+            <a:srgbClr val="F7C92D"/>
           </a:solidFill>
           <a:ln w="12700">
             <a:solidFill>
-              <a:srgbClr val="F2A900"/>
+              <a:srgbClr val="F7C92D"/>
             </a:solidFill>
             <a:prstDash val="solid"/>
           </a:ln>
@@ -11444,11 +11444,11 @@
             <a:avLst/>
           </a:prstGeom>
           <a:solidFill>
-            <a:srgbClr val="F2A900"/>
+            <a:srgbClr val="F7C92D"/>
           </a:solidFill>
           <a:ln w="12700">
             <a:solidFill>
-              <a:srgbClr val="F2A900"/>
+              <a:srgbClr val="F7C92D"/>
             </a:solidFill>
             <a:prstDash val="solid"/>
           </a:ln>
@@ -11588,11 +11588,11 @@
             </a:avLst>
           </a:prstGeom>
           <a:solidFill>
-            <a:srgbClr val="FFF4D6"/>
+            <a:srgbClr val="FFF9E0"/>
           </a:solidFill>
           <a:ln w="12700">
             <a:solidFill>
-              <a:srgbClr val="FFF4D6"/>
+              <a:srgbClr val="FFF9E0"/>
             </a:solidFill>
             <a:prstDash val="solid"/>
           </a:ln>
@@ -11984,11 +11984,11 @@
             <a:avLst/>
           </a:prstGeom>
           <a:solidFill>
-            <a:srgbClr val="F2A900"/>
+            <a:srgbClr val="F7C92D"/>
           </a:solidFill>
           <a:ln w="12700">
             <a:solidFill>
-              <a:srgbClr val="F2A900"/>
+              <a:srgbClr val="F7C92D"/>
             </a:solidFill>
             <a:prstDash val="solid"/>
           </a:ln>
@@ -12111,11 +12111,11 @@
             <a:avLst/>
           </a:prstGeom>
           <a:solidFill>
-            <a:srgbClr val="F2A900"/>
+            <a:srgbClr val="F7C92D"/>
           </a:solidFill>
           <a:ln w="12700">
             <a:solidFill>
-              <a:srgbClr val="F2A900"/>
+              <a:srgbClr val="F7C92D"/>
             </a:solidFill>
             <a:prstDash val="solid"/>
           </a:ln>
@@ -12238,11 +12238,11 @@
             <a:avLst/>
           </a:prstGeom>
           <a:solidFill>
-            <a:srgbClr val="F2A900"/>
+            <a:srgbClr val="F7C92D"/>
           </a:solidFill>
           <a:ln w="12700">
             <a:solidFill>
-              <a:srgbClr val="F2A900"/>
+              <a:srgbClr val="F7C92D"/>
             </a:solidFill>
             <a:prstDash val="solid"/>
           </a:ln>
@@ -12365,11 +12365,11 @@
             <a:avLst/>
           </a:prstGeom>
           <a:solidFill>
-            <a:srgbClr val="F2A900"/>
+            <a:srgbClr val="F7C92D"/>
           </a:solidFill>
           <a:ln w="12700">
             <a:solidFill>
-              <a:srgbClr val="F2A900"/>
+              <a:srgbClr val="F7C92D"/>
             </a:solidFill>
             <a:prstDash val="solid"/>
           </a:ln>
@@ -12492,11 +12492,11 @@
             <a:avLst/>
           </a:prstGeom>
           <a:solidFill>
-            <a:srgbClr val="F2A900"/>
+            <a:srgbClr val="F7C92D"/>
           </a:solidFill>
           <a:ln w="12700">
             <a:solidFill>
-              <a:srgbClr val="F2A900"/>
+              <a:srgbClr val="F7C92D"/>
             </a:solidFill>
             <a:prstDash val="solid"/>
           </a:ln>
@@ -12827,11 +12827,11 @@
             <a:avLst/>
           </a:prstGeom>
           <a:solidFill>
-            <a:srgbClr val="F2A900"/>
+            <a:srgbClr val="F7C92D"/>
           </a:solidFill>
           <a:ln w="12700">
             <a:solidFill>
-              <a:srgbClr val="F2A900"/>
+              <a:srgbClr val="F7C92D"/>
             </a:solidFill>
             <a:prstDash val="solid"/>
           </a:ln>
@@ -12981,11 +12981,11 @@
             <a:avLst/>
           </a:prstGeom>
           <a:solidFill>
-            <a:srgbClr val="F2A900"/>
+            <a:srgbClr val="F7C92D"/>
           </a:solidFill>
           <a:ln w="12700">
             <a:solidFill>
-              <a:srgbClr val="F2A900"/>
+              <a:srgbClr val="F7C92D"/>
             </a:solidFill>
             <a:prstDash val="solid"/>
           </a:ln>
@@ -13135,11 +13135,11 @@
             <a:avLst/>
           </a:prstGeom>
           <a:solidFill>
-            <a:srgbClr val="F2A900"/>
+            <a:srgbClr val="F7C92D"/>
           </a:solidFill>
           <a:ln w="12700">
             <a:solidFill>
-              <a:srgbClr val="F2A900"/>
+              <a:srgbClr val="F7C92D"/>
             </a:solidFill>
             <a:prstDash val="solid"/>
           </a:ln>
@@ -13289,11 +13289,11 @@
             <a:avLst/>
           </a:prstGeom>
           <a:solidFill>
-            <a:srgbClr val="F2A900"/>
+            <a:srgbClr val="F7C92D"/>
           </a:solidFill>
           <a:ln w="12700">
             <a:solidFill>
-              <a:srgbClr val="F2A900"/>
+              <a:srgbClr val="F7C92D"/>
             </a:solidFill>
             <a:prstDash val="solid"/>
           </a:ln>
@@ -13443,11 +13443,11 @@
             <a:avLst/>
           </a:prstGeom>
           <a:solidFill>
-            <a:srgbClr val="F2A900"/>
+            <a:srgbClr val="F7C92D"/>
           </a:solidFill>
           <a:ln w="12700">
             <a:solidFill>
-              <a:srgbClr val="F2A900"/>
+              <a:srgbClr val="F7C92D"/>
             </a:solidFill>
             <a:prstDash val="solid"/>
           </a:ln>
@@ -13597,11 +13597,11 @@
             <a:avLst/>
           </a:prstGeom>
           <a:solidFill>
-            <a:srgbClr val="F2A900"/>
+            <a:srgbClr val="F7C92D"/>
           </a:solidFill>
           <a:ln w="12700">
             <a:solidFill>
-              <a:srgbClr val="F2A900"/>
+              <a:srgbClr val="F7C92D"/>
             </a:solidFill>
             <a:prstDash val="solid"/>
           </a:ln>
@@ -14884,11 +14884,11 @@
             <a:avLst/>
           </a:prstGeom>
           <a:solidFill>
-            <a:srgbClr val="F2A900"/>
+            <a:srgbClr val="F7C92D"/>
           </a:solidFill>
           <a:ln w="12700">
             <a:solidFill>
-              <a:srgbClr val="F2A900"/>
+              <a:srgbClr val="F7C92D"/>
             </a:solidFill>
             <a:prstDash val="solid"/>
           </a:ln>
@@ -15144,11 +15144,11 @@
             <a:avLst/>
           </a:prstGeom>
           <a:solidFill>
-            <a:srgbClr val="F2A900"/>
+            <a:srgbClr val="F7C92D"/>
           </a:solidFill>
           <a:ln w="12700">
             <a:solidFill>
-              <a:srgbClr val="F2A900"/>
+              <a:srgbClr val="F7C92D"/>
             </a:solidFill>
             <a:prstDash val="solid"/>
           </a:ln>
@@ -15410,7 +15410,7 @@
         <p:spPr>
           <a:xfrm>
             <a:off x="7635240" y="2103120"/>
-            <a:ext cx="4053535" cy="1718729"/>
+            <a:ext cx="4053535" cy="1886474"/>
           </a:xfrm>
           <a:prstGeom prst="rect">
             <a:avLst/>
@@ -15450,7 +15450,7 @@
         <p:spPr>
           <a:xfrm>
             <a:off x="7680960" y="2148840"/>
-            <a:ext cx="3962095" cy="1627289"/>
+            <a:ext cx="3962095" cy="1795034"/>
           </a:xfrm>
           <a:prstGeom prst="rect">
             <a:avLst/>
@@ -15465,7 +15465,7 @@
         </p:nvSpPr>
         <p:spPr>
           <a:xfrm>
-            <a:off x="7680960" y="3959009"/>
+            <a:off x="7680960" y="4126754"/>
             <a:ext cx="3962095" cy="548640"/>
           </a:xfrm>
           <a:prstGeom prst="rect">
@@ -15512,7 +15512,7 @@
         </p:blipFill>
         <p:spPr>
           <a:xfrm>
-            <a:off x="7680960" y="4699673"/>
+            <a:off x="7680960" y="4867418"/>
             <a:ext cx="182880" cy="182880"/>
           </a:xfrm>
           <a:prstGeom prst="rect">
@@ -15528,7 +15528,7 @@
         </p:nvSpPr>
         <p:spPr>
           <a:xfrm>
-            <a:off x="8001000" y="4644809"/>
+            <a:off x="8001000" y="4812554"/>
             <a:ext cx="3642055" cy="292608"/>
           </a:xfrm>
           <a:prstGeom prst="rect">
@@ -15575,7 +15575,7 @@
         </p:blipFill>
         <p:spPr>
           <a:xfrm>
-            <a:off x="7680960" y="5047145"/>
+            <a:off x="7680960" y="5214890"/>
             <a:ext cx="182880" cy="182880"/>
           </a:xfrm>
           <a:prstGeom prst="rect">
@@ -15591,7 +15591,7 @@
         </p:nvSpPr>
         <p:spPr>
           <a:xfrm>
-            <a:off x="8001000" y="4992281"/>
+            <a:off x="8001000" y="5160026"/>
             <a:ext cx="3642055" cy="292608"/>
           </a:xfrm>
           <a:prstGeom prst="rect">
@@ -15638,7 +15638,7 @@
         </p:blipFill>
         <p:spPr>
           <a:xfrm>
-            <a:off x="7680960" y="5394617"/>
+            <a:off x="7680960" y="5562362"/>
             <a:ext cx="182880" cy="182880"/>
           </a:xfrm>
           <a:prstGeom prst="rect">
@@ -15654,7 +15654,7 @@
         </p:nvSpPr>
         <p:spPr>
           <a:xfrm>
-            <a:off x="8001000" y="5339753"/>
+            <a:off x="8001000" y="5507498"/>
             <a:ext cx="3642055" cy="292608"/>
           </a:xfrm>
           <a:prstGeom prst="rect">
@@ -15701,7 +15701,7 @@
         </p:blipFill>
         <p:spPr>
           <a:xfrm>
-            <a:off x="7680960" y="5742089"/>
+            <a:off x="7680960" y="5909834"/>
             <a:ext cx="182880" cy="182880"/>
           </a:xfrm>
           <a:prstGeom prst="rect">
@@ -15717,7 +15717,7 @@
         </p:nvSpPr>
         <p:spPr>
           <a:xfrm>
-            <a:off x="8001000" y="5687225"/>
+            <a:off x="8001000" y="5854970"/>
             <a:ext cx="3642055" cy="292608"/>
           </a:xfrm>
           <a:prstGeom prst="rect">

</xml_diff>